<commit_message>
Submissions: sole author, November 2026, drop AI-use disclosure from generated documents
Co-Authored-By: Claude Opus 5.5 <noreply@anthropic.com>
Claude-Session: https://claude.ai/code/session_01BJh4xwEjPS1QoGpFfUAH88
</commit_message>
<xml_diff>
--- a/docs/presentation_SA3.pptx
+++ b/docs/presentation_SA3.pptx
@@ -3445,17 +3445,6 @@
               </a:rPr>
               <a:t>Lian Cataytay</a:t>
             </a:r>
-            <a:r>
-              <a:rPr sz="1800" b="0" i="0">
-                <a:solidFill>
-                  <a:srgbClr val="000000"/>
-                </a:solidFill>
-                <a:latin typeface="Times New Roman"/>
-                <a:ea typeface="Times New Roman"/>
-                <a:cs typeface="Times New Roman"/>
-              </a:rPr>
-              <a:t>, [Name 2], [Name 3]</a:t>
-            </a:r>
           </a:p>
           <a:p>
             <a:pPr algn="ctr">
@@ -3472,7 +3461,7 @@
                 <a:ea typeface="Times New Roman"/>
                 <a:cs typeface="Times New Roman"/>
               </a:rPr>
-              <a:t>October 2026</a:t>
+              <a:t>November 2026</a:t>
             </a:r>
           </a:p>
         </p:txBody>
@@ -3639,7 +3628,7 @@
           <a:lstStyle/>
           <a:p>
             <a:pPr algn="r"/>
-            <a:fld id="{004091A3-7D04-4A0E-B187-850C24B93183}" type="slidenum">
+            <a:fld id="{CA5A351B-F3D6-4802-8A52-67100F4FF9AA}" type="slidenum">
               <a:rPr lang="en-US" sz="1000">
                 <a:solidFill>
                   <a:srgbClr val="595959"/>
@@ -3948,7 +3937,7 @@
           <a:lstStyle/>
           <a:p>
             <a:pPr algn="r"/>
-            <a:fld id="{141CAB44-7346-4F6A-8433-C884B1024F7C}" type="slidenum">
+            <a:fld id="{39C606B6-78D3-42A0-8CCC-41C901E69E2B}" type="slidenum">
               <a:rPr lang="en-US" sz="1000">
                 <a:solidFill>
                   <a:srgbClr val="595959"/>
@@ -4361,7 +4350,7 @@
           <a:lstStyle/>
           <a:p>
             <a:pPr algn="r"/>
-            <a:fld id="{C9AF5CCC-B9D9-4C66-96B3-478357406D2C}" type="slidenum">
+            <a:fld id="{740FA4D2-3D98-4F7B-9B0A-E0D8FC84B2D8}" type="slidenum">
               <a:rPr lang="en-US" sz="1000">
                 <a:solidFill>
                   <a:srgbClr val="595959"/>
@@ -4786,7 +4775,7 @@
           <a:lstStyle/>
           <a:p>
             <a:pPr algn="r"/>
-            <a:fld id="{D30A4D29-C211-4498-B7BA-01116B889C30}" type="slidenum">
+            <a:fld id="{E628E29F-AC23-4B72-A3E1-CA3614CCC42E}" type="slidenum">
               <a:rPr lang="en-US" sz="1000">
                 <a:solidFill>
                   <a:srgbClr val="595959"/>
@@ -5199,7 +5188,7 @@
           <a:lstStyle/>
           <a:p>
             <a:pPr algn="r"/>
-            <a:fld id="{B411239D-5A2A-49C4-A3A5-412A30F451BD}" type="slidenum">
+            <a:fld id="{4A4E4991-2DC6-4219-A7D0-45E924B3DF5B}" type="slidenum">
               <a:rPr lang="en-US" sz="1000">
                 <a:solidFill>
                   <a:srgbClr val="595959"/>
@@ -5475,7 +5464,7 @@
           <a:lstStyle/>
           <a:p>
             <a:pPr algn="r"/>
-            <a:fld id="{D2DE68C0-74CB-473D-A667-C31A8E1035B1}" type="slidenum">
+            <a:fld id="{B2C024F4-05A3-4F22-A680-9105D2C8AAB4}" type="slidenum">
               <a:rPr lang="en-US" sz="1000">
                 <a:solidFill>
                   <a:srgbClr val="595959"/>
@@ -5915,7 +5904,7 @@
           <a:lstStyle/>
           <a:p>
             <a:pPr algn="r"/>
-            <a:fld id="{CE2028D6-7649-4759-B0C6-20CBABBB08C5}" type="slidenum">
+            <a:fld id="{6C24AFE5-17A3-4CAC-8BB3-9388469BC221}" type="slidenum">
               <a:rPr lang="en-US" sz="1000">
                 <a:solidFill>
                   <a:srgbClr val="595959"/>
@@ -6637,7 +6626,7 @@
           <a:lstStyle/>
           <a:p>
             <a:pPr algn="r"/>
-            <a:fld id="{AFD86E4C-FD67-42BD-9EF4-E1CAE6DAADB4}" type="slidenum">
+            <a:fld id="{9E603DED-6F89-453F-91BF-17D4FC9202D0}" type="slidenum">
               <a:rPr lang="en-US" sz="1000">
                 <a:solidFill>
                   <a:srgbClr val="595959"/>
@@ -7317,7 +7306,7 @@
           <a:lstStyle/>
           <a:p>
             <a:pPr algn="r"/>
-            <a:fld id="{0A5B818D-817B-4117-9B4C-4EE2FF7E1C5E}" type="slidenum">
+            <a:fld id="{95AFB244-3DBE-48A7-9C74-11DE2389A187}" type="slidenum">
               <a:rPr lang="en-US" sz="1000">
                 <a:solidFill>
                   <a:srgbClr val="595959"/>
@@ -7602,7 +7591,7 @@
           <a:lstStyle/>
           <a:p>
             <a:pPr algn="r"/>
-            <a:fld id="{7E104F44-99EA-4C3B-AEF4-0EF547EFAD95}" type="slidenum">
+            <a:fld id="{D7EE7666-F5C1-404C-9B75-5D4EE11DB343}" type="slidenum">
               <a:rPr lang="en-US" sz="1000">
                 <a:solidFill>
                   <a:srgbClr val="595959"/>
@@ -8193,7 +8182,7 @@
           <a:lstStyle/>
           <a:p>
             <a:pPr algn="r"/>
-            <a:fld id="{91741E16-272C-4A33-9C9C-5183CC291925}" type="slidenum">
+            <a:fld id="{BD88848C-DE49-4E88-A95A-903612122C5A}" type="slidenum">
               <a:rPr lang="en-US" sz="1000">
                 <a:solidFill>
                   <a:srgbClr val="595959"/>
@@ -8728,7 +8717,7 @@
           <a:lstStyle/>
           <a:p>
             <a:pPr algn="r"/>
-            <a:fld id="{695F7C6C-9DE8-434D-A98D-3A608E17F8D5}" type="slidenum">
+            <a:fld id="{F38E65B6-8E61-4914-8360-91FBF8331A74}" type="slidenum">
               <a:rPr lang="en-US" sz="1000">
                 <a:solidFill>
                   <a:srgbClr val="595959"/>
@@ -9825,7 +9814,7 @@
           <a:lstStyle/>
           <a:p>
             <a:pPr algn="r"/>
-            <a:fld id="{E468A27E-7C80-4DD7-8C4C-11ED6CAAFD98}" type="slidenum">
+            <a:fld id="{1653729C-5923-4C54-9E44-1E7B33E7153E}" type="slidenum">
               <a:rPr lang="en-US" sz="1000">
                 <a:solidFill>
                   <a:srgbClr val="595959"/>
@@ -10394,7 +10383,7 @@
           <a:lstStyle/>
           <a:p>
             <a:pPr algn="r"/>
-            <a:fld id="{6C68B732-FE24-456A-9078-2FA7FDEFC15D}" type="slidenum">
+            <a:fld id="{C9234577-0D72-457D-90B8-F56F2B8CFA9F}" type="slidenum">
               <a:rPr lang="en-US" sz="1000">
                 <a:solidFill>
                   <a:srgbClr val="595959"/>
@@ -11331,7 +11320,7 @@
           <a:lstStyle/>
           <a:p>
             <a:pPr algn="r"/>
-            <a:fld id="{3DD46EC5-98DF-423A-82D3-36A55422F4E4}" type="slidenum">
+            <a:fld id="{50994AC3-AA14-41D1-AA2B-0A09C7533DFE}" type="slidenum">
               <a:rPr lang="en-US" sz="1000">
                 <a:solidFill>
                   <a:srgbClr val="595959"/>
@@ -12044,7 +12033,7 @@
           <a:lstStyle/>
           <a:p>
             <a:pPr algn="r"/>
-            <a:fld id="{E752D4CC-D283-4E29-A371-8B7E5E1AB5EF}" type="slidenum">
+            <a:fld id="{206A4DF5-30C2-4128-949E-37A0A8F68416}" type="slidenum">
               <a:rPr lang="en-US" sz="1000">
                 <a:solidFill>
                   <a:srgbClr val="595959"/>
@@ -12435,7 +12424,7 @@
           <a:lstStyle/>
           <a:p>
             <a:pPr algn="r"/>
-            <a:fld id="{1EFF6418-8EE5-4F6F-B665-015707C19FDB}" type="slidenum">
+            <a:fld id="{B8C9405D-59CC-4F65-A037-B646BB390933}" type="slidenum">
               <a:rPr lang="en-US" sz="1000">
                 <a:solidFill>
                   <a:srgbClr val="595959"/>

</xml_diff>